<commit_message>
Updated Reviewer Guide with Clash Resolution instructions
</commit_message>
<xml_diff>
--- a/docs/CitationReviewerGuide.pptx
+++ b/docs/CitationReviewerGuide.pptx
@@ -15,16 +15,20 @@
     <p:sldId id="267" r:id="rId9"/>
     <p:sldId id="268" r:id="rId10"/>
     <p:sldId id="275" r:id="rId11"/>
-    <p:sldId id="269" r:id="rId12"/>
-    <p:sldId id="270" r:id="rId13"/>
-    <p:sldId id="276" r:id="rId14"/>
-    <p:sldId id="271" r:id="rId15"/>
-    <p:sldId id="272" r:id="rId16"/>
-    <p:sldId id="273" r:id="rId17"/>
-    <p:sldId id="263" r:id="rId18"/>
-    <p:sldId id="261" r:id="rId19"/>
-    <p:sldId id="262" r:id="rId20"/>
-    <p:sldId id="274" r:id="rId21"/>
+    <p:sldId id="277" r:id="rId12"/>
+    <p:sldId id="278" r:id="rId13"/>
+    <p:sldId id="279" r:id="rId14"/>
+    <p:sldId id="280" r:id="rId15"/>
+    <p:sldId id="269" r:id="rId16"/>
+    <p:sldId id="270" r:id="rId17"/>
+    <p:sldId id="276" r:id="rId18"/>
+    <p:sldId id="271" r:id="rId19"/>
+    <p:sldId id="272" r:id="rId20"/>
+    <p:sldId id="273" r:id="rId21"/>
+    <p:sldId id="263" r:id="rId22"/>
+    <p:sldId id="261" r:id="rId23"/>
+    <p:sldId id="262" r:id="rId24"/>
+    <p:sldId id="274" r:id="rId25"/>
   </p:sldIdLst>
   <p:sldSz cx="12192000" cy="6858000"/>
   <p:notesSz cx="6858000" cy="9144000"/>
@@ -278,7 +282,7 @@
           <a:p>
             <a:fld id="{A570D5E4-9820-8A4C-880B-D00DFB29381F}" type="datetimeFigureOut">
               <a:rPr lang="en-GB" smtClean="0"/>
-              <a:t>01/09/2026</a:t>
+              <a:t>17/09/2026</a:t>
             </a:fld>
             <a:endParaRPr lang="en-GB"/>
           </a:p>
@@ -476,7 +480,7 @@
           <a:p>
             <a:fld id="{A570D5E4-9820-8A4C-880B-D00DFB29381F}" type="datetimeFigureOut">
               <a:rPr lang="en-GB" smtClean="0"/>
-              <a:t>01/09/2026</a:t>
+              <a:t>17/09/2026</a:t>
             </a:fld>
             <a:endParaRPr lang="en-GB"/>
           </a:p>
@@ -684,7 +688,7 @@
           <a:p>
             <a:fld id="{A570D5E4-9820-8A4C-880B-D00DFB29381F}" type="datetimeFigureOut">
               <a:rPr lang="en-GB" smtClean="0"/>
-              <a:t>01/09/2026</a:t>
+              <a:t>17/09/2026</a:t>
             </a:fld>
             <a:endParaRPr lang="en-GB"/>
           </a:p>
@@ -882,7 +886,7 @@
           <a:p>
             <a:fld id="{A570D5E4-9820-8A4C-880B-D00DFB29381F}" type="datetimeFigureOut">
               <a:rPr lang="en-GB" smtClean="0"/>
-              <a:t>01/09/2026</a:t>
+              <a:t>17/09/2026</a:t>
             </a:fld>
             <a:endParaRPr lang="en-GB"/>
           </a:p>
@@ -1157,7 +1161,7 @@
           <a:p>
             <a:fld id="{A570D5E4-9820-8A4C-880B-D00DFB29381F}" type="datetimeFigureOut">
               <a:rPr lang="en-GB" smtClean="0"/>
-              <a:t>01/09/2026</a:t>
+              <a:t>17/09/2026</a:t>
             </a:fld>
             <a:endParaRPr lang="en-GB"/>
           </a:p>
@@ -1422,7 +1426,7 @@
           <a:p>
             <a:fld id="{A570D5E4-9820-8A4C-880B-D00DFB29381F}" type="datetimeFigureOut">
               <a:rPr lang="en-GB" smtClean="0"/>
-              <a:t>01/09/2026</a:t>
+              <a:t>17/09/2026</a:t>
             </a:fld>
             <a:endParaRPr lang="en-GB"/>
           </a:p>
@@ -1834,7 +1838,7 @@
           <a:p>
             <a:fld id="{A570D5E4-9820-8A4C-880B-D00DFB29381F}" type="datetimeFigureOut">
               <a:rPr lang="en-GB" smtClean="0"/>
-              <a:t>01/09/2026</a:t>
+              <a:t>17/09/2026</a:t>
             </a:fld>
             <a:endParaRPr lang="en-GB"/>
           </a:p>
@@ -1975,7 +1979,7 @@
           <a:p>
             <a:fld id="{A570D5E4-9820-8A4C-880B-D00DFB29381F}" type="datetimeFigureOut">
               <a:rPr lang="en-GB" smtClean="0"/>
-              <a:t>01/09/2026</a:t>
+              <a:t>17/09/2026</a:t>
             </a:fld>
             <a:endParaRPr lang="en-GB"/>
           </a:p>
@@ -2088,7 +2092,7 @@
           <a:p>
             <a:fld id="{A570D5E4-9820-8A4C-880B-D00DFB29381F}" type="datetimeFigureOut">
               <a:rPr lang="en-GB" smtClean="0"/>
-              <a:t>01/09/2026</a:t>
+              <a:t>17/09/2026</a:t>
             </a:fld>
             <a:endParaRPr lang="en-GB"/>
           </a:p>
@@ -2399,7 +2403,7 @@
           <a:p>
             <a:fld id="{A570D5E4-9820-8A4C-880B-D00DFB29381F}" type="datetimeFigureOut">
               <a:rPr lang="en-GB" smtClean="0"/>
-              <a:t>01/09/2026</a:t>
+              <a:t>17/09/2026</a:t>
             </a:fld>
             <a:endParaRPr lang="en-GB"/>
           </a:p>
@@ -2687,7 +2691,7 @@
           <a:p>
             <a:fld id="{A570D5E4-9820-8A4C-880B-D00DFB29381F}" type="datetimeFigureOut">
               <a:rPr lang="en-GB" smtClean="0"/>
-              <a:t>01/09/2026</a:t>
+              <a:t>17/09/2026</a:t>
             </a:fld>
             <a:endParaRPr lang="en-GB"/>
           </a:p>
@@ -2928,7 +2932,7 @@
           <a:p>
             <a:fld id="{A570D5E4-9820-8A4C-880B-D00DFB29381F}" type="datetimeFigureOut">
               <a:rPr lang="en-GB" smtClean="0"/>
-              <a:t>01/09/2026</a:t>
+              <a:t>17/09/2026</a:t>
             </a:fld>
             <a:endParaRPr lang="en-GB"/>
           </a:p>
@@ -3416,7 +3420,7 @@
         <p:spPr>
           <a:xfrm>
             <a:off x="251460" y="6240780"/>
-            <a:ext cx="11740137" cy="369332"/>
+            <a:ext cx="12018355" cy="369332"/>
           </a:xfrm>
           <a:prstGeom prst="rect">
             <a:avLst/>
@@ -3441,15 +3445,7 @@
             </a:r>
             <a:r>
               <a:rPr lang="en-GB" dirty="0"/>
-              <a:t>) 				Last Updated 1</a:t>
-            </a:r>
-            <a:r>
-              <a:rPr lang="en-GB" baseline="30000" dirty="0"/>
-              <a:t>st</a:t>
-            </a:r>
-            <a:r>
-              <a:rPr lang="en-GB" dirty="0"/>
-              <a:t> September 2026</a:t>
+              <a:t>) 				Last Updated 17th September 2026</a:t>
             </a:r>
           </a:p>
         </p:txBody>
@@ -3664,6 +3660,1006 @@
         <p:cNvPr id="1" name="">
           <a:extLst>
             <a:ext uri="{FF2B5EF4-FFF2-40B4-BE49-F238E27FC236}">
+              <a16:creationId xmlns:a16="http://schemas.microsoft.com/office/drawing/2014/main" id="{E062B7BD-4485-1527-58CD-66249D68B5B8}"/>
+            </a:ext>
+          </a:extLst>
+        </p:cNvPr>
+        <p:cNvGrpSpPr/>
+        <p:nvPr/>
+      </p:nvGrpSpPr>
+      <p:grpSpPr>
+        <a:xfrm>
+          <a:off x="0" y="0"/>
+          <a:ext cx="0" cy="0"/>
+          <a:chOff x="0" y="0"/>
+          <a:chExt cx="0" cy="0"/>
+        </a:xfrm>
+      </p:grpSpPr>
+      <p:sp>
+        <p:nvSpPr>
+          <p:cNvPr id="2" name="Title 1">
+            <a:extLst>
+              <a:ext uri="{FF2B5EF4-FFF2-40B4-BE49-F238E27FC236}">
+                <a16:creationId xmlns:a16="http://schemas.microsoft.com/office/drawing/2014/main" id="{2A33BEE7-FB0A-C695-D542-DC7FE2862941}"/>
+              </a:ext>
+            </a:extLst>
+          </p:cNvPr>
+          <p:cNvSpPr>
+            <a:spLocks noGrp="1"/>
+          </p:cNvSpPr>
+          <p:nvPr>
+            <p:ph type="title"/>
+          </p:nvPr>
+        </p:nvSpPr>
+        <p:spPr>
+          <a:xfrm>
+            <a:off x="376518" y="223413"/>
+            <a:ext cx="11739282" cy="1325563"/>
+          </a:xfrm>
+        </p:spPr>
+        <p:txBody>
+          <a:bodyPr/>
+          <a:lstStyle/>
+          <a:p>
+            <a:r>
+              <a:rPr lang="en-GB" dirty="0"/>
+              <a:t>Editing Citation Records (UI) – Clashing Information</a:t>
+            </a:r>
+          </a:p>
+        </p:txBody>
+      </p:sp>
+      <p:sp>
+        <p:nvSpPr>
+          <p:cNvPr id="5" name="Content Placeholder 4">
+            <a:extLst>
+              <a:ext uri="{FF2B5EF4-FFF2-40B4-BE49-F238E27FC236}">
+                <a16:creationId xmlns:a16="http://schemas.microsoft.com/office/drawing/2014/main" id="{9DD870B8-523F-8B44-F192-C057BB2D64F1}"/>
+              </a:ext>
+            </a:extLst>
+          </p:cNvPr>
+          <p:cNvSpPr>
+            <a:spLocks noGrp="1"/>
+          </p:cNvSpPr>
+          <p:nvPr>
+            <p:ph idx="1"/>
+          </p:nvPr>
+        </p:nvSpPr>
+        <p:spPr>
+          <a:xfrm>
+            <a:off x="518746" y="1344704"/>
+            <a:ext cx="10747131" cy="5407787"/>
+          </a:xfrm>
+        </p:spPr>
+        <p:txBody>
+          <a:bodyPr>
+            <a:normAutofit/>
+          </a:bodyPr>
+          <a:lstStyle/>
+          <a:p>
+            <a:pPr marL="0" indent="0">
+              <a:buNone/>
+            </a:pPr>
+            <a:r>
+              <a:rPr lang="en-GB" dirty="0"/>
+              <a:t>If a Party already exists in the citation service with </a:t>
+            </a:r>
+            <a:r>
+              <a:rPr lang="en-GB" b="1" dirty="0"/>
+              <a:t>different </a:t>
+            </a:r>
+            <a:r>
+              <a:rPr lang="en-GB" dirty="0"/>
+              <a:t>information, this raises a clash error.</a:t>
+            </a:r>
+          </a:p>
+          <a:p>
+            <a:pPr marL="0" indent="0">
+              <a:buNone/>
+            </a:pPr>
+            <a:endParaRPr lang="en-GB" dirty="0"/>
+          </a:p>
+          <a:p>
+            <a:pPr marL="514350" indent="-514350">
+              <a:buAutoNum type="arabicPeriod"/>
+            </a:pPr>
+            <a:r>
+              <a:rPr lang="en-GB" dirty="0"/>
+              <a:t>If the new information overrides some old information (</a:t>
+            </a:r>
+            <a:r>
+              <a:rPr lang="en-GB" dirty="0" err="1"/>
+              <a:t>i.e</a:t>
+            </a:r>
+            <a:r>
+              <a:rPr lang="en-GB" dirty="0"/>
+              <a:t> an email update/change) then you can </a:t>
+            </a:r>
+            <a:r>
+              <a:rPr lang="en-GB" b="1" dirty="0"/>
+              <a:t>ignore the warning </a:t>
+            </a:r>
+            <a:r>
+              <a:rPr lang="en-GB" dirty="0"/>
+              <a:t>and just resubmit the form and this error will be bypassed.</a:t>
+            </a:r>
+          </a:p>
+          <a:p>
+            <a:pPr marL="514350" indent="-514350">
+              <a:buAutoNum type="arabicPeriod"/>
+            </a:pPr>
+            <a:endParaRPr lang="en-GB" dirty="0"/>
+          </a:p>
+          <a:p>
+            <a:pPr marL="514350" indent="-514350">
+              <a:buAutoNum type="arabicPeriod"/>
+            </a:pPr>
+            <a:r>
+              <a:rPr lang="en-GB" dirty="0"/>
+              <a:t>If the clash could indicate two different people with the same name (but different emails/</a:t>
+            </a:r>
+            <a:r>
+              <a:rPr lang="en-GB" dirty="0" err="1"/>
+              <a:t>orcids</a:t>
+            </a:r>
+            <a:r>
+              <a:rPr lang="en-GB" dirty="0"/>
+              <a:t>) you will need to check the </a:t>
+            </a:r>
+            <a:r>
+              <a:rPr lang="en-GB" b="1" dirty="0"/>
+              <a:t>Parties</a:t>
+            </a:r>
+            <a:r>
+              <a:rPr lang="en-GB" dirty="0"/>
+              <a:t> information that currently exists and determine the best response.</a:t>
+            </a:r>
+          </a:p>
+        </p:txBody>
+      </p:sp>
+    </p:spTree>
+    <p:extLst>
+      <p:ext uri="{BB962C8B-B14F-4D97-AF65-F5344CB8AC3E}">
+        <p14:creationId xmlns:p14="http://schemas.microsoft.com/office/powerpoint/2010/main" val="2104520070"/>
+      </p:ext>
+    </p:extLst>
+  </p:cSld>
+  <p:clrMapOvr>
+    <a:masterClrMapping/>
+  </p:clrMapOvr>
+</p:sld>
+</file>
+
+<file path=ppt/slides/slide12.xml><?xml version="1.0" encoding="utf-8"?>
+<p:sld xmlns:a="http://schemas.openxmlformats.org/drawingml/2006/main" xmlns:r="http://schemas.openxmlformats.org/officeDocument/2006/relationships" xmlns:p="http://schemas.openxmlformats.org/presentationml/2006/main">
+  <p:cSld>
+    <p:spTree>
+      <p:nvGrpSpPr>
+        <p:cNvPr id="1" name="">
+          <a:extLst>
+            <a:ext uri="{FF2B5EF4-FFF2-40B4-BE49-F238E27FC236}">
+              <a16:creationId xmlns:a16="http://schemas.microsoft.com/office/drawing/2014/main" id="{C9D9450C-EEA8-F2CD-3991-22A3AE04C781}"/>
+            </a:ext>
+          </a:extLst>
+        </p:cNvPr>
+        <p:cNvGrpSpPr/>
+        <p:nvPr/>
+      </p:nvGrpSpPr>
+      <p:grpSpPr>
+        <a:xfrm>
+          <a:off x="0" y="0"/>
+          <a:ext cx="0" cy="0"/>
+          <a:chOff x="0" y="0"/>
+          <a:chExt cx="0" cy="0"/>
+        </a:xfrm>
+      </p:grpSpPr>
+      <p:sp>
+        <p:nvSpPr>
+          <p:cNvPr id="2" name="Title 1">
+            <a:extLst>
+              <a:ext uri="{FF2B5EF4-FFF2-40B4-BE49-F238E27FC236}">
+                <a16:creationId xmlns:a16="http://schemas.microsoft.com/office/drawing/2014/main" id="{D8BD9BCB-9BFE-4E6A-093E-DB617E538C83}"/>
+              </a:ext>
+            </a:extLst>
+          </p:cNvPr>
+          <p:cNvSpPr>
+            <a:spLocks noGrp="1"/>
+          </p:cNvSpPr>
+          <p:nvPr>
+            <p:ph type="title"/>
+          </p:nvPr>
+        </p:nvSpPr>
+        <p:spPr>
+          <a:xfrm>
+            <a:off x="376518" y="223413"/>
+            <a:ext cx="11739282" cy="1325563"/>
+          </a:xfrm>
+        </p:spPr>
+        <p:txBody>
+          <a:bodyPr/>
+          <a:lstStyle/>
+          <a:p>
+            <a:r>
+              <a:rPr lang="en-GB" dirty="0"/>
+              <a:t>Editing Citation Records (UI) – Clashing Information</a:t>
+            </a:r>
+          </a:p>
+        </p:txBody>
+      </p:sp>
+      <p:pic>
+        <p:nvPicPr>
+          <p:cNvPr id="6" name="Picture 5">
+            <a:extLst>
+              <a:ext uri="{FF2B5EF4-FFF2-40B4-BE49-F238E27FC236}">
+                <a16:creationId xmlns:a16="http://schemas.microsoft.com/office/drawing/2014/main" id="{98BAD744-34C7-40E4-AF53-0175D0CB86F8}"/>
+              </a:ext>
+            </a:extLst>
+          </p:cNvPr>
+          <p:cNvPicPr>
+            <a:picLocks noChangeAspect="1"/>
+          </p:cNvPicPr>
+          <p:nvPr/>
+        </p:nvPicPr>
+        <p:blipFill>
+          <a:blip r:embed="rId2"/>
+          <a:stretch>
+            <a:fillRect/>
+          </a:stretch>
+        </p:blipFill>
+        <p:spPr>
+          <a:xfrm>
+            <a:off x="460131" y="1284243"/>
+            <a:ext cx="11402098" cy="3146355"/>
+          </a:xfrm>
+          <a:prstGeom prst="rect">
+            <a:avLst/>
+          </a:prstGeom>
+        </p:spPr>
+      </p:pic>
+    </p:spTree>
+    <p:extLst>
+      <p:ext uri="{BB962C8B-B14F-4D97-AF65-F5344CB8AC3E}">
+        <p14:creationId xmlns:p14="http://schemas.microsoft.com/office/powerpoint/2010/main" val="2766356244"/>
+      </p:ext>
+    </p:extLst>
+  </p:cSld>
+  <p:clrMapOvr>
+    <a:masterClrMapping/>
+  </p:clrMapOvr>
+</p:sld>
+</file>
+
+<file path=ppt/slides/slide13.xml><?xml version="1.0" encoding="utf-8"?>
+<p:sld xmlns:a="http://schemas.openxmlformats.org/drawingml/2006/main" xmlns:r="http://schemas.openxmlformats.org/officeDocument/2006/relationships" xmlns:p="http://schemas.openxmlformats.org/presentationml/2006/main">
+  <p:cSld>
+    <p:spTree>
+      <p:nvGrpSpPr>
+        <p:cNvPr id="1" name="">
+          <a:extLst>
+            <a:ext uri="{FF2B5EF4-FFF2-40B4-BE49-F238E27FC236}">
+              <a16:creationId xmlns:a16="http://schemas.microsoft.com/office/drawing/2014/main" id="{8A8E797C-CD22-ED0C-EB8C-6C8ABA0BB314}"/>
+            </a:ext>
+          </a:extLst>
+        </p:cNvPr>
+        <p:cNvGrpSpPr/>
+        <p:nvPr/>
+      </p:nvGrpSpPr>
+      <p:grpSpPr>
+        <a:xfrm>
+          <a:off x="0" y="0"/>
+          <a:ext cx="0" cy="0"/>
+          <a:chOff x="0" y="0"/>
+          <a:chExt cx="0" cy="0"/>
+        </a:xfrm>
+      </p:grpSpPr>
+      <p:sp>
+        <p:nvSpPr>
+          <p:cNvPr id="2" name="Title 1">
+            <a:extLst>
+              <a:ext uri="{FF2B5EF4-FFF2-40B4-BE49-F238E27FC236}">
+                <a16:creationId xmlns:a16="http://schemas.microsoft.com/office/drawing/2014/main" id="{ABE37000-6AA2-60F0-77E4-C3ADD19AD60F}"/>
+              </a:ext>
+            </a:extLst>
+          </p:cNvPr>
+          <p:cNvSpPr>
+            <a:spLocks noGrp="1"/>
+          </p:cNvSpPr>
+          <p:nvPr>
+            <p:ph type="title"/>
+          </p:nvPr>
+        </p:nvSpPr>
+        <p:spPr>
+          <a:xfrm>
+            <a:off x="376518" y="223413"/>
+            <a:ext cx="11739282" cy="1325563"/>
+          </a:xfrm>
+        </p:spPr>
+        <p:txBody>
+          <a:bodyPr/>
+          <a:lstStyle/>
+          <a:p>
+            <a:r>
+              <a:rPr lang="en-GB" dirty="0"/>
+              <a:t>Editing Citation Records (UI) – Clashing Information</a:t>
+            </a:r>
+          </a:p>
+        </p:txBody>
+      </p:sp>
+      <p:pic>
+        <p:nvPicPr>
+          <p:cNvPr id="6" name="Picture 5">
+            <a:extLst>
+              <a:ext uri="{FF2B5EF4-FFF2-40B4-BE49-F238E27FC236}">
+                <a16:creationId xmlns:a16="http://schemas.microsoft.com/office/drawing/2014/main" id="{873E68CE-4EA0-E029-AF36-9815D243BB0A}"/>
+              </a:ext>
+            </a:extLst>
+          </p:cNvPr>
+          <p:cNvPicPr>
+            <a:picLocks noChangeAspect="1"/>
+          </p:cNvPicPr>
+          <p:nvPr/>
+        </p:nvPicPr>
+        <p:blipFill>
+          <a:blip r:embed="rId2"/>
+          <a:stretch>
+            <a:fillRect/>
+          </a:stretch>
+        </p:blipFill>
+        <p:spPr>
+          <a:xfrm>
+            <a:off x="460131" y="1284243"/>
+            <a:ext cx="11402098" cy="3146355"/>
+          </a:xfrm>
+          <a:prstGeom prst="rect">
+            <a:avLst/>
+          </a:prstGeom>
+        </p:spPr>
+      </p:pic>
+      <p:sp>
+        <p:nvSpPr>
+          <p:cNvPr id="7" name="Oval 6">
+            <a:extLst>
+              <a:ext uri="{FF2B5EF4-FFF2-40B4-BE49-F238E27FC236}">
+                <a16:creationId xmlns:a16="http://schemas.microsoft.com/office/drawing/2014/main" id="{46CFF875-A6E0-67C7-BE48-7B6FEE1CBA64}"/>
+              </a:ext>
+            </a:extLst>
+          </p:cNvPr>
+          <p:cNvSpPr/>
+          <p:nvPr/>
+        </p:nvSpPr>
+        <p:spPr>
+          <a:xfrm>
+            <a:off x="1649691" y="3355942"/>
+            <a:ext cx="1310325" cy="282804"/>
+          </a:xfrm>
+          <a:prstGeom prst="ellipse">
+            <a:avLst/>
+          </a:prstGeom>
+          <a:noFill/>
+          <a:ln>
+            <a:solidFill>
+              <a:srgbClr val="FF0000"/>
+            </a:solidFill>
+          </a:ln>
+        </p:spPr>
+        <p:style>
+          <a:lnRef idx="2">
+            <a:schemeClr val="accent1">
+              <a:shade val="15000"/>
+            </a:schemeClr>
+          </a:lnRef>
+          <a:fillRef idx="1">
+            <a:schemeClr val="accent1"/>
+          </a:fillRef>
+          <a:effectRef idx="0">
+            <a:schemeClr val="accent1"/>
+          </a:effectRef>
+          <a:fontRef idx="minor">
+            <a:schemeClr val="lt1"/>
+          </a:fontRef>
+        </p:style>
+        <p:txBody>
+          <a:bodyPr rtlCol="0" anchor="ctr"/>
+          <a:lstStyle/>
+          <a:p>
+            <a:pPr algn="ctr"/>
+            <a:endParaRPr lang="en-GB"/>
+          </a:p>
+        </p:txBody>
+      </p:sp>
+      <p:sp>
+        <p:nvSpPr>
+          <p:cNvPr id="3" name="Oval 2">
+            <a:extLst>
+              <a:ext uri="{FF2B5EF4-FFF2-40B4-BE49-F238E27FC236}">
+                <a16:creationId xmlns:a16="http://schemas.microsoft.com/office/drawing/2014/main" id="{2AB5B922-9010-05BE-0698-67E2B8654290}"/>
+              </a:ext>
+            </a:extLst>
+          </p:cNvPr>
+          <p:cNvSpPr/>
+          <p:nvPr/>
+        </p:nvSpPr>
+        <p:spPr>
+          <a:xfrm>
+            <a:off x="4545291" y="3355942"/>
+            <a:ext cx="2110033" cy="282804"/>
+          </a:xfrm>
+          <a:prstGeom prst="ellipse">
+            <a:avLst/>
+          </a:prstGeom>
+          <a:noFill/>
+          <a:ln>
+            <a:solidFill>
+              <a:srgbClr val="FF0000"/>
+            </a:solidFill>
+          </a:ln>
+        </p:spPr>
+        <p:style>
+          <a:lnRef idx="2">
+            <a:schemeClr val="accent1">
+              <a:shade val="15000"/>
+            </a:schemeClr>
+          </a:lnRef>
+          <a:fillRef idx="1">
+            <a:schemeClr val="accent1"/>
+          </a:fillRef>
+          <a:effectRef idx="0">
+            <a:schemeClr val="accent1"/>
+          </a:effectRef>
+          <a:fontRef idx="minor">
+            <a:schemeClr val="lt1"/>
+          </a:fontRef>
+        </p:style>
+        <p:txBody>
+          <a:bodyPr rtlCol="0" anchor="ctr"/>
+          <a:lstStyle/>
+          <a:p>
+            <a:pPr algn="ctr"/>
+            <a:endParaRPr lang="en-GB"/>
+          </a:p>
+        </p:txBody>
+      </p:sp>
+      <p:sp>
+        <p:nvSpPr>
+          <p:cNvPr id="4" name="Oval 3">
+            <a:extLst>
+              <a:ext uri="{FF2B5EF4-FFF2-40B4-BE49-F238E27FC236}">
+                <a16:creationId xmlns:a16="http://schemas.microsoft.com/office/drawing/2014/main" id="{1A3ABF30-CD11-2421-95EC-55DB29AB217E}"/>
+              </a:ext>
+            </a:extLst>
+          </p:cNvPr>
+          <p:cNvSpPr/>
+          <p:nvPr/>
+        </p:nvSpPr>
+        <p:spPr>
+          <a:xfrm>
+            <a:off x="1021237" y="3610466"/>
+            <a:ext cx="2551522" cy="282804"/>
+          </a:xfrm>
+          <a:prstGeom prst="ellipse">
+            <a:avLst/>
+          </a:prstGeom>
+          <a:noFill/>
+          <a:ln>
+            <a:solidFill>
+              <a:srgbClr val="FF0000"/>
+            </a:solidFill>
+          </a:ln>
+        </p:spPr>
+        <p:style>
+          <a:lnRef idx="2">
+            <a:schemeClr val="accent1">
+              <a:shade val="15000"/>
+            </a:schemeClr>
+          </a:lnRef>
+          <a:fillRef idx="1">
+            <a:schemeClr val="accent1"/>
+          </a:fillRef>
+          <a:effectRef idx="0">
+            <a:schemeClr val="accent1"/>
+          </a:effectRef>
+          <a:fontRef idx="minor">
+            <a:schemeClr val="lt1"/>
+          </a:fontRef>
+        </p:style>
+        <p:txBody>
+          <a:bodyPr rtlCol="0" anchor="ctr"/>
+          <a:lstStyle/>
+          <a:p>
+            <a:pPr algn="ctr"/>
+            <a:endParaRPr lang="en-GB"/>
+          </a:p>
+        </p:txBody>
+      </p:sp>
+      <p:sp>
+        <p:nvSpPr>
+          <p:cNvPr id="5" name="TextBox 4">
+            <a:extLst>
+              <a:ext uri="{FF2B5EF4-FFF2-40B4-BE49-F238E27FC236}">
+                <a16:creationId xmlns:a16="http://schemas.microsoft.com/office/drawing/2014/main" id="{D135371B-9C22-EB32-1DF8-96A69B1DF999}"/>
+              </a:ext>
+            </a:extLst>
+          </p:cNvPr>
+          <p:cNvSpPr txBox="1"/>
+          <p:nvPr/>
+        </p:nvSpPr>
+        <p:spPr>
+          <a:xfrm>
+            <a:off x="744718" y="4500456"/>
+            <a:ext cx="6340069" cy="369332"/>
+          </a:xfrm>
+          <a:prstGeom prst="rect">
+            <a:avLst/>
+          </a:prstGeom>
+          <a:noFill/>
+        </p:spPr>
+        <p:txBody>
+          <a:bodyPr wrap="none" rtlCol="0">
+            <a:spAutoFit/>
+          </a:bodyPr>
+          <a:lstStyle/>
+          <a:p>
+            <a:r>
+              <a:rPr lang="en-GB" dirty="0"/>
+              <a:t>Existing user: Daniel Westwood (</a:t>
+            </a:r>
+            <a:r>
+              <a:rPr lang="en-GB" dirty="0" err="1"/>
+              <a:t>daniel.westwood@stfc.ac.uk</a:t>
+            </a:r>
+            <a:r>
+              <a:rPr lang="en-GB" dirty="0"/>
+              <a:t>)</a:t>
+            </a:r>
+          </a:p>
+        </p:txBody>
+      </p:sp>
+      <p:sp>
+        <p:nvSpPr>
+          <p:cNvPr id="8" name="Rectangle 7">
+            <a:extLst>
+              <a:ext uri="{FF2B5EF4-FFF2-40B4-BE49-F238E27FC236}">
+                <a16:creationId xmlns:a16="http://schemas.microsoft.com/office/drawing/2014/main" id="{15F3B42D-0427-F832-DA44-EE35218757E6}"/>
+              </a:ext>
+            </a:extLst>
+          </p:cNvPr>
+          <p:cNvSpPr/>
+          <p:nvPr/>
+        </p:nvSpPr>
+        <p:spPr>
+          <a:xfrm>
+            <a:off x="460130" y="4869787"/>
+            <a:ext cx="5384489" cy="1764799"/>
+          </a:xfrm>
+          <a:prstGeom prst="rect">
+            <a:avLst/>
+          </a:prstGeom>
+        </p:spPr>
+        <p:style>
+          <a:lnRef idx="2">
+            <a:schemeClr val="accent6"/>
+          </a:lnRef>
+          <a:fillRef idx="1">
+            <a:schemeClr val="lt1"/>
+          </a:fillRef>
+          <a:effectRef idx="0">
+            <a:schemeClr val="accent6"/>
+          </a:effectRef>
+          <a:fontRef idx="minor">
+            <a:schemeClr val="dk1"/>
+          </a:fontRef>
+        </p:style>
+        <p:txBody>
+          <a:bodyPr rtlCol="0" anchor="ctr"/>
+          <a:lstStyle/>
+          <a:p>
+            <a:pPr algn="ctr"/>
+            <a:r>
+              <a:rPr lang="en-GB" u="sng" dirty="0"/>
+              <a:t>Information Update</a:t>
+            </a:r>
+          </a:p>
+          <a:p>
+            <a:r>
+              <a:rPr lang="en-GB" dirty="0"/>
+              <a:t>Daniel Westwood email should not be @</a:t>
+            </a:r>
+            <a:r>
+              <a:rPr lang="en-GB" dirty="0" err="1"/>
+              <a:t>stfc.ac.uk</a:t>
+            </a:r>
+            <a:r>
+              <a:rPr lang="en-GB" dirty="0"/>
+              <a:t>. Information should be updated to the correct email, so this warning can be ignored.</a:t>
+            </a:r>
+          </a:p>
+        </p:txBody>
+      </p:sp>
+      <p:sp>
+        <p:nvSpPr>
+          <p:cNvPr id="10" name="Rectangle 9">
+            <a:extLst>
+              <a:ext uri="{FF2B5EF4-FFF2-40B4-BE49-F238E27FC236}">
+                <a16:creationId xmlns:a16="http://schemas.microsoft.com/office/drawing/2014/main" id="{237FFFF4-1A49-A5F2-E08E-E654B450AE0A}"/>
+              </a:ext>
+            </a:extLst>
+          </p:cNvPr>
+          <p:cNvSpPr/>
+          <p:nvPr/>
+        </p:nvSpPr>
+        <p:spPr>
+          <a:xfrm>
+            <a:off x="6347381" y="4869786"/>
+            <a:ext cx="5384489" cy="1764800"/>
+          </a:xfrm>
+          <a:prstGeom prst="rect">
+            <a:avLst/>
+          </a:prstGeom>
+        </p:spPr>
+        <p:style>
+          <a:lnRef idx="2">
+            <a:schemeClr val="accent6"/>
+          </a:lnRef>
+          <a:fillRef idx="1">
+            <a:schemeClr val="lt1"/>
+          </a:fillRef>
+          <a:effectRef idx="0">
+            <a:schemeClr val="accent6"/>
+          </a:effectRef>
+          <a:fontRef idx="minor">
+            <a:schemeClr val="dk1"/>
+          </a:fontRef>
+        </p:style>
+        <p:txBody>
+          <a:bodyPr rtlCol="0" anchor="ctr"/>
+          <a:lstStyle/>
+          <a:p>
+            <a:pPr algn="ctr"/>
+            <a:r>
+              <a:rPr lang="en-GB" sz="1600" u="sng" dirty="0"/>
+              <a:t>Different person</a:t>
+            </a:r>
+          </a:p>
+          <a:p>
+            <a:r>
+              <a:rPr lang="en-GB" sz="1600" dirty="0"/>
+              <a:t>Daniel Westwood (STFC) and Daniel Westwood (Met Office) are </a:t>
+            </a:r>
+            <a:r>
+              <a:rPr lang="en-GB" sz="1600" b="1" dirty="0"/>
+              <a:t>two different people</a:t>
+            </a:r>
+            <a:r>
+              <a:rPr lang="en-GB" sz="1600" dirty="0"/>
+              <a:t>. You will need to add </a:t>
+            </a:r>
+            <a:r>
+              <a:rPr lang="en-GB" sz="1600" b="1" dirty="0"/>
+              <a:t>middle name information</a:t>
+            </a:r>
+            <a:r>
+              <a:rPr lang="en-GB" sz="1600" dirty="0"/>
+              <a:t> to the new Party to distinguish from the existing Party. If this cannot be completed, contact the CEDA Helpdesk for assistance resolving the issue.</a:t>
+            </a:r>
+          </a:p>
+        </p:txBody>
+      </p:sp>
+    </p:spTree>
+    <p:extLst>
+      <p:ext uri="{BB962C8B-B14F-4D97-AF65-F5344CB8AC3E}">
+        <p14:creationId xmlns:p14="http://schemas.microsoft.com/office/powerpoint/2010/main" val="263164699"/>
+      </p:ext>
+    </p:extLst>
+  </p:cSld>
+  <p:clrMapOvr>
+    <a:masterClrMapping/>
+  </p:clrMapOvr>
+</p:sld>
+</file>
+
+<file path=ppt/slides/slide14.xml><?xml version="1.0" encoding="utf-8"?>
+<p:sld xmlns:a="http://schemas.openxmlformats.org/drawingml/2006/main" xmlns:r="http://schemas.openxmlformats.org/officeDocument/2006/relationships" xmlns:p="http://schemas.openxmlformats.org/presentationml/2006/main">
+  <p:cSld>
+    <p:spTree>
+      <p:nvGrpSpPr>
+        <p:cNvPr id="1" name="">
+          <a:extLst>
+            <a:ext uri="{FF2B5EF4-FFF2-40B4-BE49-F238E27FC236}">
+              <a16:creationId xmlns:a16="http://schemas.microsoft.com/office/drawing/2014/main" id="{8EE44AA4-1799-CDB8-1C61-D2E46A937147}"/>
+            </a:ext>
+          </a:extLst>
+        </p:cNvPr>
+        <p:cNvGrpSpPr/>
+        <p:nvPr/>
+      </p:nvGrpSpPr>
+      <p:grpSpPr>
+        <a:xfrm>
+          <a:off x="0" y="0"/>
+          <a:ext cx="0" cy="0"/>
+          <a:chOff x="0" y="0"/>
+          <a:chExt cx="0" cy="0"/>
+        </a:xfrm>
+      </p:grpSpPr>
+      <p:sp>
+        <p:nvSpPr>
+          <p:cNvPr id="2" name="Title 1">
+            <a:extLst>
+              <a:ext uri="{FF2B5EF4-FFF2-40B4-BE49-F238E27FC236}">
+                <a16:creationId xmlns:a16="http://schemas.microsoft.com/office/drawing/2014/main" id="{BBDA569D-9177-2BA7-866D-5C5C2741CFA4}"/>
+              </a:ext>
+            </a:extLst>
+          </p:cNvPr>
+          <p:cNvSpPr>
+            <a:spLocks noGrp="1"/>
+          </p:cNvSpPr>
+          <p:nvPr>
+            <p:ph type="title"/>
+          </p:nvPr>
+        </p:nvSpPr>
+        <p:spPr>
+          <a:xfrm>
+            <a:off x="376518" y="223413"/>
+            <a:ext cx="11739282" cy="1325563"/>
+          </a:xfrm>
+        </p:spPr>
+        <p:txBody>
+          <a:bodyPr/>
+          <a:lstStyle/>
+          <a:p>
+            <a:r>
+              <a:rPr lang="en-GB" dirty="0"/>
+              <a:t>Editing Citation Records (UI) – Clashing Information</a:t>
+            </a:r>
+          </a:p>
+        </p:txBody>
+      </p:sp>
+      <p:pic>
+        <p:nvPicPr>
+          <p:cNvPr id="13" name="Picture 12">
+            <a:extLst>
+              <a:ext uri="{FF2B5EF4-FFF2-40B4-BE49-F238E27FC236}">
+                <a16:creationId xmlns:a16="http://schemas.microsoft.com/office/drawing/2014/main" id="{A2BE0574-C631-BD1B-10E6-BE3316108D25}"/>
+              </a:ext>
+            </a:extLst>
+          </p:cNvPr>
+          <p:cNvPicPr>
+            <a:picLocks noChangeAspect="1"/>
+          </p:cNvPicPr>
+          <p:nvPr/>
+        </p:nvPicPr>
+        <p:blipFill>
+          <a:blip r:embed="rId2"/>
+          <a:stretch>
+            <a:fillRect/>
+          </a:stretch>
+        </p:blipFill>
+        <p:spPr>
+          <a:xfrm>
+            <a:off x="2423536" y="2020843"/>
+            <a:ext cx="7344927" cy="2499520"/>
+          </a:xfrm>
+          <a:prstGeom prst="rect">
+            <a:avLst/>
+          </a:prstGeom>
+        </p:spPr>
+      </p:pic>
+      <p:pic>
+        <p:nvPicPr>
+          <p:cNvPr id="17" name="Picture 16">
+            <a:extLst>
+              <a:ext uri="{FF2B5EF4-FFF2-40B4-BE49-F238E27FC236}">
+                <a16:creationId xmlns:a16="http://schemas.microsoft.com/office/drawing/2014/main" id="{9A9C7FD4-82F5-78E8-1166-CC8D38A48B71}"/>
+              </a:ext>
+            </a:extLst>
+          </p:cNvPr>
+          <p:cNvPicPr>
+            <a:picLocks noChangeAspect="1"/>
+          </p:cNvPicPr>
+          <p:nvPr/>
+        </p:nvPicPr>
+        <p:blipFill>
+          <a:blip r:embed="rId3"/>
+          <a:stretch>
+            <a:fillRect/>
+          </a:stretch>
+        </p:blipFill>
+        <p:spPr>
+          <a:xfrm>
+            <a:off x="175163" y="4520363"/>
+            <a:ext cx="4496745" cy="2021100"/>
+          </a:xfrm>
+          <a:prstGeom prst="rect">
+            <a:avLst/>
+          </a:prstGeom>
+        </p:spPr>
+      </p:pic>
+      <p:pic>
+        <p:nvPicPr>
+          <p:cNvPr id="21" name="Picture 20">
+            <a:extLst>
+              <a:ext uri="{FF2B5EF4-FFF2-40B4-BE49-F238E27FC236}">
+                <a16:creationId xmlns:a16="http://schemas.microsoft.com/office/drawing/2014/main" id="{80987B6F-0702-A93A-C53E-AC7BDF8829A8}"/>
+              </a:ext>
+            </a:extLst>
+          </p:cNvPr>
+          <p:cNvPicPr>
+            <a:picLocks noChangeAspect="1"/>
+          </p:cNvPicPr>
+          <p:nvPr/>
+        </p:nvPicPr>
+        <p:blipFill>
+          <a:blip r:embed="rId4"/>
+          <a:stretch>
+            <a:fillRect/>
+          </a:stretch>
+        </p:blipFill>
+        <p:spPr>
+          <a:xfrm>
+            <a:off x="7055832" y="4520363"/>
+            <a:ext cx="4496745" cy="2021100"/>
+          </a:xfrm>
+          <a:prstGeom prst="rect">
+            <a:avLst/>
+          </a:prstGeom>
+        </p:spPr>
+      </p:pic>
+      <p:cxnSp>
+        <p:nvCxnSpPr>
+          <p:cNvPr id="23" name="Straight Arrow Connector 22">
+            <a:extLst>
+              <a:ext uri="{FF2B5EF4-FFF2-40B4-BE49-F238E27FC236}">
+                <a16:creationId xmlns:a16="http://schemas.microsoft.com/office/drawing/2014/main" id="{53C6B94A-36E7-1BDF-2FFB-B0DF13F36B57}"/>
+              </a:ext>
+            </a:extLst>
+          </p:cNvPr>
+          <p:cNvCxnSpPr/>
+          <p:nvPr/>
+        </p:nvCxnSpPr>
+        <p:spPr>
+          <a:xfrm flipH="1">
+            <a:off x="1743959" y="3921551"/>
+            <a:ext cx="679576" cy="1055802"/>
+          </a:xfrm>
+          <a:prstGeom prst="straightConnector1">
+            <a:avLst/>
+          </a:prstGeom>
+          <a:ln>
+            <a:tailEnd type="triangle"/>
+          </a:ln>
+        </p:spPr>
+        <p:style>
+          <a:lnRef idx="1">
+            <a:schemeClr val="accent6"/>
+          </a:lnRef>
+          <a:fillRef idx="0">
+            <a:schemeClr val="accent6"/>
+          </a:fillRef>
+          <a:effectRef idx="0">
+            <a:schemeClr val="accent6"/>
+          </a:effectRef>
+          <a:fontRef idx="minor">
+            <a:schemeClr val="tx1"/>
+          </a:fontRef>
+        </p:style>
+      </p:cxnSp>
+      <p:cxnSp>
+        <p:nvCxnSpPr>
+          <p:cNvPr id="24" name="Straight Arrow Connector 23">
+            <a:extLst>
+              <a:ext uri="{FF2B5EF4-FFF2-40B4-BE49-F238E27FC236}">
+                <a16:creationId xmlns:a16="http://schemas.microsoft.com/office/drawing/2014/main" id="{60428544-5C22-FA33-FFD9-DC7895D17139}"/>
+              </a:ext>
+            </a:extLst>
+          </p:cNvPr>
+          <p:cNvCxnSpPr>
+            <a:cxnSpLocks/>
+          </p:cNvCxnSpPr>
+          <p:nvPr/>
+        </p:nvCxnSpPr>
+        <p:spPr>
+          <a:xfrm>
+            <a:off x="4671908" y="4281106"/>
+            <a:ext cx="2219086" cy="875356"/>
+          </a:xfrm>
+          <a:prstGeom prst="straightConnector1">
+            <a:avLst/>
+          </a:prstGeom>
+          <a:ln>
+            <a:tailEnd type="triangle"/>
+          </a:ln>
+        </p:spPr>
+        <p:style>
+          <a:lnRef idx="1">
+            <a:schemeClr val="accent6"/>
+          </a:lnRef>
+          <a:fillRef idx="0">
+            <a:schemeClr val="accent6"/>
+          </a:fillRef>
+          <a:effectRef idx="0">
+            <a:schemeClr val="accent6"/>
+          </a:effectRef>
+          <a:fontRef idx="minor">
+            <a:schemeClr val="tx1"/>
+          </a:fontRef>
+        </p:style>
+      </p:cxnSp>
+      <p:sp>
+        <p:nvSpPr>
+          <p:cNvPr id="28" name="Rectangle 27">
+            <a:extLst>
+              <a:ext uri="{FF2B5EF4-FFF2-40B4-BE49-F238E27FC236}">
+                <a16:creationId xmlns:a16="http://schemas.microsoft.com/office/drawing/2014/main" id="{D12EE6E1-DD16-45F4-8EA3-77E25F833867}"/>
+              </a:ext>
+            </a:extLst>
+          </p:cNvPr>
+          <p:cNvSpPr/>
+          <p:nvPr/>
+        </p:nvSpPr>
+        <p:spPr>
+          <a:xfrm>
+            <a:off x="412364" y="1309908"/>
+            <a:ext cx="11403118" cy="613160"/>
+          </a:xfrm>
+          <a:prstGeom prst="rect">
+            <a:avLst/>
+          </a:prstGeom>
+        </p:spPr>
+        <p:style>
+          <a:lnRef idx="2">
+            <a:schemeClr val="accent6">
+              <a:shade val="15000"/>
+            </a:schemeClr>
+          </a:lnRef>
+          <a:fillRef idx="1">
+            <a:schemeClr val="accent6"/>
+          </a:fillRef>
+          <a:effectRef idx="0">
+            <a:schemeClr val="accent6"/>
+          </a:effectRef>
+          <a:fontRef idx="minor">
+            <a:schemeClr val="lt1"/>
+          </a:fontRef>
+        </p:style>
+        <p:txBody>
+          <a:bodyPr rtlCol="0" anchor="ctr"/>
+          <a:lstStyle/>
+          <a:p>
+            <a:pPr algn="ctr"/>
+            <a:r>
+              <a:rPr lang="en-GB" dirty="0"/>
+              <a:t>Different people with the same name </a:t>
+            </a:r>
+            <a:r>
+              <a:rPr lang="en-GB" b="1" dirty="0"/>
+              <a:t>MUST</a:t>
+            </a:r>
+            <a:r>
+              <a:rPr lang="en-GB" dirty="0"/>
+              <a:t> be differentiated using middle names, even though they’re only displayed on the Party landing pages.</a:t>
+            </a:r>
+          </a:p>
+        </p:txBody>
+      </p:sp>
+    </p:spTree>
+    <p:extLst>
+      <p:ext uri="{BB962C8B-B14F-4D97-AF65-F5344CB8AC3E}">
+        <p14:creationId xmlns:p14="http://schemas.microsoft.com/office/powerpoint/2010/main" val="3829433283"/>
+      </p:ext>
+    </p:extLst>
+  </p:cSld>
+  <p:clrMapOvr>
+    <a:masterClrMapping/>
+  </p:clrMapOvr>
+</p:sld>
+</file>
+
+<file path=ppt/slides/slide15.xml><?xml version="1.0" encoding="utf-8"?>
+<p:sld xmlns:a="http://schemas.openxmlformats.org/drawingml/2006/main" xmlns:r="http://schemas.openxmlformats.org/officeDocument/2006/relationships" xmlns:p="http://schemas.openxmlformats.org/presentationml/2006/main">
+  <p:cSld>
+    <p:spTree>
+      <p:nvGrpSpPr>
+        <p:cNvPr id="1" name="">
+          <a:extLst>
+            <a:ext uri="{FF2B5EF4-FFF2-40B4-BE49-F238E27FC236}">
               <a16:creationId xmlns:a16="http://schemas.microsoft.com/office/drawing/2014/main" id="{D138A181-3329-F264-F79C-7F1F721168AC}"/>
             </a:ext>
           </a:extLst>
@@ -3796,7 +4792,7 @@
 </p:sld>
 </file>
 
-<file path=ppt/slides/slide12.xml><?xml version="1.0" encoding="utf-8"?>
+<file path=ppt/slides/slide16.xml><?xml version="1.0" encoding="utf-8"?>
 <p:sld xmlns:a="http://schemas.openxmlformats.org/drawingml/2006/main" xmlns:r="http://schemas.openxmlformats.org/officeDocument/2006/relationships" xmlns:p="http://schemas.openxmlformats.org/presentationml/2006/main">
   <p:cSld>
     <p:spTree>
@@ -3939,7 +4935,7 @@
 </p:sld>
 </file>
 
-<file path=ppt/slides/slide13.xml><?xml version="1.0" encoding="utf-8"?>
+<file path=ppt/slides/slide17.xml><?xml version="1.0" encoding="utf-8"?>
 <p:sld xmlns:a="http://schemas.openxmlformats.org/drawingml/2006/main" xmlns:r="http://schemas.openxmlformats.org/officeDocument/2006/relationships" xmlns:p="http://schemas.openxmlformats.org/presentationml/2006/main">
   <p:cSld>
     <p:spTree>
@@ -4073,7 +5069,7 @@
 </p:sld>
 </file>
 
-<file path=ppt/slides/slide14.xml><?xml version="1.0" encoding="utf-8"?>
+<file path=ppt/slides/slide18.xml><?xml version="1.0" encoding="utf-8"?>
 <p:sld xmlns:a="http://schemas.openxmlformats.org/drawingml/2006/main" xmlns:r="http://schemas.openxmlformats.org/officeDocument/2006/relationships" xmlns:p="http://schemas.openxmlformats.org/presentationml/2006/main">
   <p:cSld>
     <p:spTree>
@@ -4256,7 +5252,7 @@
 </p:sld>
 </file>
 
-<file path=ppt/slides/slide15.xml><?xml version="1.0" encoding="utf-8"?>
+<file path=ppt/slides/slide19.xml><?xml version="1.0" encoding="utf-8"?>
 <p:sld xmlns:a="http://schemas.openxmlformats.org/drawingml/2006/main" xmlns:r="http://schemas.openxmlformats.org/officeDocument/2006/relationships" xmlns:p="http://schemas.openxmlformats.org/presentationml/2006/main">
   <p:cSld>
     <p:spTree>
@@ -4407,7 +5403,123 @@
 </p:sld>
 </file>
 
-<file path=ppt/slides/slide16.xml><?xml version="1.0" encoding="utf-8"?>
+<file path=ppt/slides/slide2.xml><?xml version="1.0" encoding="utf-8"?>
+<p:sld xmlns:a="http://schemas.openxmlformats.org/drawingml/2006/main" xmlns:r="http://schemas.openxmlformats.org/officeDocument/2006/relationships" xmlns:p="http://schemas.openxmlformats.org/presentationml/2006/main">
+  <p:cSld>
+    <p:spTree>
+      <p:nvGrpSpPr>
+        <p:cNvPr id="1" name=""/>
+        <p:cNvGrpSpPr/>
+        <p:nvPr/>
+      </p:nvGrpSpPr>
+      <p:grpSpPr>
+        <a:xfrm>
+          <a:off x="0" y="0"/>
+          <a:ext cx="0" cy="0"/>
+          <a:chOff x="0" y="0"/>
+          <a:chExt cx="0" cy="0"/>
+        </a:xfrm>
+      </p:grpSpPr>
+      <p:sp>
+        <p:nvSpPr>
+          <p:cNvPr id="2" name="Title 1">
+            <a:extLst>
+              <a:ext uri="{FF2B5EF4-FFF2-40B4-BE49-F238E27FC236}">
+                <a16:creationId xmlns:a16="http://schemas.microsoft.com/office/drawing/2014/main" id="{99515705-5631-E30F-0371-9285A0EBC8C0}"/>
+              </a:ext>
+            </a:extLst>
+          </p:cNvPr>
+          <p:cNvSpPr>
+            <a:spLocks noGrp="1"/>
+          </p:cNvSpPr>
+          <p:nvPr>
+            <p:ph type="title"/>
+          </p:nvPr>
+        </p:nvSpPr>
+        <p:spPr/>
+        <p:txBody>
+          <a:bodyPr/>
+          <a:lstStyle/>
+          <a:p>
+            <a:r>
+              <a:rPr lang="en-GB" dirty="0"/>
+              <a:t>Contents</a:t>
+            </a:r>
+          </a:p>
+        </p:txBody>
+      </p:sp>
+      <p:sp>
+        <p:nvSpPr>
+          <p:cNvPr id="3" name="Content Placeholder 2">
+            <a:extLst>
+              <a:ext uri="{FF2B5EF4-FFF2-40B4-BE49-F238E27FC236}">
+                <a16:creationId xmlns:a16="http://schemas.microsoft.com/office/drawing/2014/main" id="{83761B67-4DB2-DA77-9704-948671BE5180}"/>
+              </a:ext>
+            </a:extLst>
+          </p:cNvPr>
+          <p:cNvSpPr>
+            <a:spLocks noGrp="1"/>
+          </p:cNvSpPr>
+          <p:nvPr>
+            <p:ph idx="1"/>
+          </p:nvPr>
+        </p:nvSpPr>
+        <p:spPr/>
+        <p:txBody>
+          <a:bodyPr/>
+          <a:lstStyle/>
+          <a:p>
+            <a:r>
+              <a:rPr lang="en-GB" dirty="0"/>
+              <a:t>Requesting Reviewer Access</a:t>
+            </a:r>
+          </a:p>
+          <a:p>
+            <a:r>
+              <a:rPr lang="en-GB" dirty="0"/>
+              <a:t>Editing Citation Records (UI)</a:t>
+            </a:r>
+          </a:p>
+          <a:p>
+            <a:r>
+              <a:rPr lang="en-GB" dirty="0"/>
+              <a:t>Clashing Information (UI)</a:t>
+            </a:r>
+          </a:p>
+          <a:p>
+            <a:r>
+              <a:rPr lang="en-GB" dirty="0"/>
+              <a:t>Minting DOIs (UI)</a:t>
+            </a:r>
+          </a:p>
+          <a:p>
+            <a:r>
+              <a:rPr lang="en-GB" dirty="0"/>
+              <a:t>Editing Citation Records (API)</a:t>
+            </a:r>
+          </a:p>
+          <a:p>
+            <a:r>
+              <a:rPr lang="en-GB" dirty="0"/>
+              <a:t>Minting DOIs (API)</a:t>
+            </a:r>
+          </a:p>
+        </p:txBody>
+      </p:sp>
+    </p:spTree>
+    <p:extLst>
+      <p:ext uri="{BB962C8B-B14F-4D97-AF65-F5344CB8AC3E}">
+        <p14:creationId xmlns:p14="http://schemas.microsoft.com/office/powerpoint/2010/main" val="1198418198"/>
+      </p:ext>
+    </p:extLst>
+  </p:cSld>
+  <p:clrMapOvr>
+    <a:masterClrMapping/>
+  </p:clrMapOvr>
+</p:sld>
+</file>
+
+<file path=ppt/slides/slide20.xml><?xml version="1.0" encoding="utf-8"?>
 <p:sld xmlns:a="http://schemas.openxmlformats.org/drawingml/2006/main" xmlns:r="http://schemas.openxmlformats.org/officeDocument/2006/relationships" xmlns:p="http://schemas.openxmlformats.org/presentationml/2006/main">
   <p:cSld>
     <p:spTree>
@@ -4834,7 +5946,7 @@
 </p:sld>
 </file>
 
-<file path=ppt/slides/slide17.xml><?xml version="1.0" encoding="utf-8"?>
+<file path=ppt/slides/slide21.xml><?xml version="1.0" encoding="utf-8"?>
 <p:sld xmlns:a="http://schemas.openxmlformats.org/drawingml/2006/main" xmlns:r="http://schemas.openxmlformats.org/officeDocument/2006/relationships" xmlns:p="http://schemas.openxmlformats.org/presentationml/2006/main">
   <p:cSld>
     <p:spTree>
@@ -4965,7 +6077,7 @@
 </p:sld>
 </file>
 
-<file path=ppt/slides/slide18.xml><?xml version="1.0" encoding="utf-8"?>
+<file path=ppt/slides/slide22.xml><?xml version="1.0" encoding="utf-8"?>
 <p:sld xmlns:a="http://schemas.openxmlformats.org/drawingml/2006/main" xmlns:r="http://schemas.openxmlformats.org/officeDocument/2006/relationships" xmlns:p="http://schemas.openxmlformats.org/presentationml/2006/main">
   <p:cSld>
     <p:spTree>
@@ -5187,7 +6299,7 @@
 </p:sld>
 </file>
 
-<file path=ppt/slides/slide19.xml><?xml version="1.0" encoding="utf-8"?>
+<file path=ppt/slides/slide23.xml><?xml version="1.0" encoding="utf-8"?>
 <p:sld xmlns:a="http://schemas.openxmlformats.org/drawingml/2006/main" xmlns:r="http://schemas.openxmlformats.org/officeDocument/2006/relationships" xmlns:p="http://schemas.openxmlformats.org/presentationml/2006/main">
   <p:cSld>
     <p:spTree>
@@ -5327,117 +6439,7 @@
 </p:sld>
 </file>
 
-<file path=ppt/slides/slide2.xml><?xml version="1.0" encoding="utf-8"?>
-<p:sld xmlns:a="http://schemas.openxmlformats.org/drawingml/2006/main" xmlns:r="http://schemas.openxmlformats.org/officeDocument/2006/relationships" xmlns:p="http://schemas.openxmlformats.org/presentationml/2006/main">
-  <p:cSld>
-    <p:spTree>
-      <p:nvGrpSpPr>
-        <p:cNvPr id="1" name=""/>
-        <p:cNvGrpSpPr/>
-        <p:nvPr/>
-      </p:nvGrpSpPr>
-      <p:grpSpPr>
-        <a:xfrm>
-          <a:off x="0" y="0"/>
-          <a:ext cx="0" cy="0"/>
-          <a:chOff x="0" y="0"/>
-          <a:chExt cx="0" cy="0"/>
-        </a:xfrm>
-      </p:grpSpPr>
-      <p:sp>
-        <p:nvSpPr>
-          <p:cNvPr id="2" name="Title 1">
-            <a:extLst>
-              <a:ext uri="{FF2B5EF4-FFF2-40B4-BE49-F238E27FC236}">
-                <a16:creationId xmlns:a16="http://schemas.microsoft.com/office/drawing/2014/main" id="{99515705-5631-E30F-0371-9285A0EBC8C0}"/>
-              </a:ext>
-            </a:extLst>
-          </p:cNvPr>
-          <p:cNvSpPr>
-            <a:spLocks noGrp="1"/>
-          </p:cNvSpPr>
-          <p:nvPr>
-            <p:ph type="title"/>
-          </p:nvPr>
-        </p:nvSpPr>
-        <p:spPr/>
-        <p:txBody>
-          <a:bodyPr/>
-          <a:lstStyle/>
-          <a:p>
-            <a:r>
-              <a:rPr lang="en-GB" dirty="0"/>
-              <a:t>Contents</a:t>
-            </a:r>
-          </a:p>
-        </p:txBody>
-      </p:sp>
-      <p:sp>
-        <p:nvSpPr>
-          <p:cNvPr id="3" name="Content Placeholder 2">
-            <a:extLst>
-              <a:ext uri="{FF2B5EF4-FFF2-40B4-BE49-F238E27FC236}">
-                <a16:creationId xmlns:a16="http://schemas.microsoft.com/office/drawing/2014/main" id="{83761B67-4DB2-DA77-9704-948671BE5180}"/>
-              </a:ext>
-            </a:extLst>
-          </p:cNvPr>
-          <p:cNvSpPr>
-            <a:spLocks noGrp="1"/>
-          </p:cNvSpPr>
-          <p:nvPr>
-            <p:ph idx="1"/>
-          </p:nvPr>
-        </p:nvSpPr>
-        <p:spPr/>
-        <p:txBody>
-          <a:bodyPr/>
-          <a:lstStyle/>
-          <a:p>
-            <a:r>
-              <a:rPr lang="en-GB" dirty="0"/>
-              <a:t>Requesting Reviewer Access</a:t>
-            </a:r>
-          </a:p>
-          <a:p>
-            <a:r>
-              <a:rPr lang="en-GB" dirty="0"/>
-              <a:t>Editing Citation Records (UI)</a:t>
-            </a:r>
-          </a:p>
-          <a:p>
-            <a:r>
-              <a:rPr lang="en-GB" dirty="0"/>
-              <a:t>Minting DOIs (UI)</a:t>
-            </a:r>
-          </a:p>
-          <a:p>
-            <a:r>
-              <a:rPr lang="en-GB" dirty="0"/>
-              <a:t>Editing Citation Records (API)</a:t>
-            </a:r>
-          </a:p>
-          <a:p>
-            <a:r>
-              <a:rPr lang="en-GB" dirty="0"/>
-              <a:t>Minting DOIs (API)</a:t>
-            </a:r>
-          </a:p>
-        </p:txBody>
-      </p:sp>
-    </p:spTree>
-    <p:extLst>
-      <p:ext uri="{BB962C8B-B14F-4D97-AF65-F5344CB8AC3E}">
-        <p14:creationId xmlns:p14="http://schemas.microsoft.com/office/powerpoint/2010/main" val="1198418198"/>
-      </p:ext>
-    </p:extLst>
-  </p:cSld>
-  <p:clrMapOvr>
-    <a:masterClrMapping/>
-  </p:clrMapOvr>
-</p:sld>
-</file>
-
-<file path=ppt/slides/slide20.xml><?xml version="1.0" encoding="utf-8"?>
+<file path=ppt/slides/slide24.xml><?xml version="1.0" encoding="utf-8"?>
 <p:sld xmlns:a="http://schemas.openxmlformats.org/drawingml/2006/main" xmlns:r="http://schemas.openxmlformats.org/officeDocument/2006/relationships" xmlns:p="http://schemas.openxmlformats.org/presentationml/2006/main">
   <p:cSld>
     <p:spTree>

</xml_diff>